<commit_message>
Clarify LSB needle entry point spec and fix figure label
- Technique slide now states the entry point explicitly: prone position,
  paravertebral approach, ~7 cm lateral to midline, 30-45 deg medial
  angulation, 22 G 15 cm needle, contact lateral vertebral body then walk
  anteromedially to the anterolateral surface.
- Fix axial schematic label that said the needle walks "anterolaterally"
  (the movement is anteromedial; the anterolateral surface is the target).
- Mirror the same wording in the web deck, native pptx and StatPearls
  evidence card; regenerate figure PNGs, decks and reference PDFs.

Co-Authored-By: Claude Opus 5 <noreply@anthropic.com>
Claude-Session: https://claude.ai/code/session_01DtjcgiLXhNebAtJykVQjDA
</commit_message>
<xml_diff>
--- a/문헌고찰_NLC_RLS_LSB/03_LSB/LSB_발표.pptx
+++ b/문헌고찰_NLC_RLS_LSB/03_LSB/LSB_발표.pptx
@@ -3863,8 +3863,8 @@
         </p:blipFill>
         <p:spPr>
           <a:xfrm>
-            <a:off x="2156145" y="1417320"/>
-            <a:ext cx="7879404" cy="4114800"/>
+            <a:off x="2158240" y="1417320"/>
+            <a:ext cx="7875215" cy="4114800"/>
           </a:xfrm>
           <a:prstGeom prst="rect">
             <a:avLst/>
@@ -15170,7 +15170,7 @@
                 <a:latin typeface="NanumGothic"/>
                 <a:ea typeface="NanumGothic"/>
               </a:rPr>
-              <a:t>표준: 방척추(paravertebral) 접근 + 투시 (CT·초음파도 가능)</a:t>
+              <a:t>복와위 · 방척추(paravertebral) 접근 + 투시 (CT·초음파 가능)</a:t>
             </a:r>
           </a:p>
           <a:p>
@@ -15193,6 +15193,36 @@
               <a:t>●  </a:t>
             </a:r>
             <a:r>
+              <a:rPr sz="1350" b="1" i="0">
+                <a:solidFill>
+                  <a:srgbClr val="1A202C"/>
+                </a:solidFill>
+                <a:latin typeface="NanumGothic"/>
+                <a:ea typeface="NanumGothic"/>
+              </a:rPr>
+              <a:t>자입점: 정중선 ~7 cm 외측 · 내측 경사 30–45°</a:t>
+            </a:r>
+          </a:p>
+          <a:p>
+            <a:pPr algn="l">
+              <a:lnSpc>
+                <a:spcPct val="108000"/>
+              </a:lnSpc>
+              <a:spcAft>
+                <a:spcPts val="900"/>
+              </a:spcAft>
+            </a:pPr>
+            <a:r>
+              <a:rPr sz="944" b="1" i="0">
+                <a:solidFill>
+                  <a:srgbClr val="2C898A"/>
+                </a:solidFill>
+                <a:latin typeface="NanumGothic"/>
+                <a:ea typeface="NanumGothic"/>
+              </a:rPr>
+              <a:t>●  </a:t>
+            </a:r>
+            <a:r>
               <a:rPr sz="1350" b="0" i="0">
                 <a:solidFill>
                   <a:srgbClr val="1A202C"/>
@@ -15200,7 +15230,7 @@
                 <a:latin typeface="NanumGothic"/>
                 <a:ea typeface="NanumGothic"/>
               </a:rPr>
-              <a:t>바늘: 정중선 ~7 cm 외측 → 척추체 접촉 후 전내측 'walk'</a:t>
+              <a:t>바늘 22 G 15 cm → 척추체 외측면 접촉 → 전내측 'walk' → 전외측면</a:t>
             </a:r>
           </a:p>
           <a:p>
@@ -15223,14 +15253,14 @@
               <a:t>●  </a:t>
             </a:r>
             <a:r>
-              <a:rPr sz="1350" b="0" i="0">
+              <a:rPr sz="1350" b="1" i="0">
                 <a:solidFill>
                   <a:srgbClr val="1A202C"/>
                 </a:solidFill>
                 <a:latin typeface="NanumGothic"/>
                 <a:ea typeface="NanumGothic"/>
               </a:rPr>
-              <a:t>조영제로 두미측 종방향 확산 확인</a:t>
+              <a:t>조영제 두미측 종방향 확산 · 성공지표 온도 ≥2°C↑</a:t>
             </a:r>
           </a:p>
           <a:p>
@@ -15243,54 +15273,24 @@
               </a:spcAft>
             </a:pPr>
             <a:r>
-              <a:rPr sz="944" b="1" i="0">
-                <a:solidFill>
-                  <a:srgbClr val="2C898A"/>
-                </a:solidFill>
-                <a:latin typeface="NanumGothic"/>
-                <a:ea typeface="NanumGothic"/>
-              </a:rPr>
-              <a:t>●  </a:t>
-            </a:r>
-            <a:r>
               <a:rPr sz="1350" b="1" i="0">
                 <a:solidFill>
-                  <a:srgbClr val="1A202C"/>
-                </a:solidFill>
-                <a:latin typeface="NanumGothic"/>
-                <a:ea typeface="NanumGothic"/>
-              </a:rPr>
-              <a:t>성공 지표: 피부온도 ≥2°C 상승</a:t>
-            </a:r>
-          </a:p>
-          <a:p>
-            <a:pPr algn="l">
-              <a:lnSpc>
-                <a:spcPct val="108000"/>
-              </a:lnSpc>
-              <a:spcAft>
-                <a:spcPts val="900"/>
-              </a:spcAft>
-            </a:pPr>
+                  <a:srgbClr val="5A6B7B"/>
+                </a:solidFill>
+                <a:latin typeface="NanumGothic"/>
+                <a:ea typeface="NanumGothic"/>
+              </a:rPr>
+              <a:t/>
+            </a:r>
             <a:r>
               <a:rPr sz="1350" b="1" i="0">
                 <a:solidFill>
-                  <a:srgbClr val="5A6B7B"/>
-                </a:solidFill>
-                <a:latin typeface="NanumGothic"/>
-                <a:ea typeface="NanumGothic"/>
-              </a:rPr>
-              <a:t/>
-            </a:r>
-            <a:r>
-              <a:rPr sz="1350" b="1" i="0">
-                <a:solidFill>
                   <a:srgbClr val="1F6E70"/>
                 </a:solidFill>
                 <a:latin typeface="NanumGothic"/>
                 <a:ea typeface="NanumGothic"/>
               </a:rPr>
-              <a:t>약제: 국소마취제 / 신경파괴(무수알코올·phenol·RFA)는 진단차단 양성 시에만</a:t>
+              <a:t>약제: 국소마취제 / 신경파괴는 진단차단 양성 시에만</a:t>
             </a:r>
           </a:p>
         </p:txBody>
@@ -15359,8 +15359,8 @@
         </p:blipFill>
         <p:spPr>
           <a:xfrm>
-            <a:off x="7178040" y="1958147"/>
-            <a:ext cx="4251960" cy="3444625"/>
+            <a:off x="7178040" y="1957087"/>
+            <a:ext cx="4251960" cy="3446745"/>
           </a:xfrm>
           <a:prstGeom prst="rect">
             <a:avLst/>
@@ -16272,8 +16272,8 @@
         </p:blipFill>
         <p:spPr>
           <a:xfrm>
-            <a:off x="2323947" y="1417320"/>
-            <a:ext cx="7543800" cy="4023360"/>
+            <a:off x="2326892" y="1417320"/>
+            <a:ext cx="7537911" cy="4023360"/>
           </a:xfrm>
           <a:prstGeom prst="rect">
             <a:avLst/>
@@ -17320,8 +17320,8 @@
         </p:blipFill>
         <p:spPr>
           <a:xfrm>
-            <a:off x="2033578" y="1417320"/>
-            <a:ext cx="8124539" cy="3977639"/>
+            <a:off x="2037032" y="1417320"/>
+            <a:ext cx="8117631" cy="3977639"/>
           </a:xfrm>
           <a:prstGeom prst="rect">
             <a:avLst/>

</xml_diff>

<commit_message>
Describe LSB first position via C-arm oblique 30-35 degrees
Technique slide now states the initial setup the way it is actually done:
C-arm obliqued 30-35 degrees to the block side until the transverse
process tip overlaps the lateral margin of the vertebral body, skin entry
marked directly over the target on that view (~7 cm lateral to midline),
then coaxial (tunnel-view) advancement of a 22 G 15 cm needle.

Also updates the axial schematic label, the StatPearls evidence card and
the key-message slide, and tightens the key-message rows so all five fit.

Co-Authored-By: Claude Opus 5 <noreply@anthropic.com>
Claude-Session: https://claude.ai/code/session_01DtjcgiLXhNebAtJykVQjDA
</commit_message>
<xml_diff>
--- a/문헌고찰_NLC_RLS_LSB/03_LSB/LSB_발표.pptx
+++ b/문헌고찰_NLC_RLS_LSB/03_LSB/LSB_발표.pptx
@@ -11282,7 +11282,7 @@
                 <a:latin typeface="NanumGothic"/>
                 <a:ea typeface="NanumGothic"/>
               </a:rPr>
-              <a:t>L2–L3 방척추 접근·투시, 정중선 7 cm 외측, 조영제 두미측 확산, 성공지표 온도 ≥2°C.</a:t>
+              <a:t>L2–L3 방척추 접근 · C-arm 사위 30–35°로 첫 위치 → 동축 진입</a:t>
             </a:r>
           </a:p>
         </p:txBody>
@@ -15170,7 +15170,7 @@
                 <a:latin typeface="NanumGothic"/>
                 <a:ea typeface="NanumGothic"/>
               </a:rPr>
-              <a:t>복와위 · 방척추(paravertebral) 접근 + 투시 (CT·초음파 가능)</a:t>
+              <a:t>복와위 · 투시 유도 방척추(paravertebral) 접근 (CT·초음파 가능)</a:t>
             </a:r>
           </a:p>
           <a:p>
@@ -15200,7 +15200,7 @@
                 <a:latin typeface="NanumGothic"/>
                 <a:ea typeface="NanumGothic"/>
               </a:rPr>
-              <a:t>자입점: 정중선 ~7 cm 외측 · 내측 경사 30–45°</a:t>
+              <a:t>첫 위치: C-arm 환측 30–35° 사위(oblique) — 횡돌기 끝이 척추체 외측연에 겹치게</a:t>
             </a:r>
           </a:p>
           <a:p>
@@ -15223,6 +15223,36 @@
               <a:t>●  </a:t>
             </a:r>
             <a:r>
+              <a:rPr sz="1350" b="1" i="0">
+                <a:solidFill>
+                  <a:srgbClr val="1A202C"/>
+                </a:solidFill>
+                <a:latin typeface="NanumGothic"/>
+                <a:ea typeface="NanumGothic"/>
+              </a:rPr>
+              <a:t>자입점: 그 상에서 표적 바로 위 피부(정중선 ~7 cm) · 빔과 동축(tunnel view)</a:t>
+            </a:r>
+          </a:p>
+          <a:p>
+            <a:pPr algn="l">
+              <a:lnSpc>
+                <a:spcPct val="108000"/>
+              </a:lnSpc>
+              <a:spcAft>
+                <a:spcPts val="900"/>
+              </a:spcAft>
+            </a:pPr>
+            <a:r>
+              <a:rPr sz="944" b="1" i="0">
+                <a:solidFill>
+                  <a:srgbClr val="2C898A"/>
+                </a:solidFill>
+                <a:latin typeface="NanumGothic"/>
+                <a:ea typeface="NanumGothic"/>
+              </a:rPr>
+              <a:t>●  </a:t>
+            </a:r>
+            <a:r>
               <a:rPr sz="1350" b="0" i="0">
                 <a:solidFill>
                   <a:srgbClr val="1A202C"/>
@@ -15230,7 +15260,7 @@
                 <a:latin typeface="NanumGothic"/>
                 <a:ea typeface="NanumGothic"/>
               </a:rPr>
-              <a:t>바늘 22 G 15 cm → 척추체 외측면 접촉 → 전내측 'walk' → 전외측면</a:t>
+              <a:t>22 G 15 cm → 척추체 외측면 접촉 → 전내측 'walk' → 전외측면</a:t>
             </a:r>
           </a:p>
           <a:p>
@@ -15243,54 +15273,24 @@
               </a:spcAft>
             </a:pPr>
             <a:r>
-              <a:rPr sz="944" b="1" i="0">
-                <a:solidFill>
-                  <a:srgbClr val="2C898A"/>
-                </a:solidFill>
-                <a:latin typeface="NanumGothic"/>
-                <a:ea typeface="NanumGothic"/>
-              </a:rPr>
-              <a:t>●  </a:t>
-            </a:r>
-            <a:r>
               <a:rPr sz="1350" b="1" i="0">
                 <a:solidFill>
-                  <a:srgbClr val="1A202C"/>
-                </a:solidFill>
-                <a:latin typeface="NanumGothic"/>
-                <a:ea typeface="NanumGothic"/>
-              </a:rPr>
-              <a:t>조영제 두미측 종방향 확산 · 성공지표 온도 ≥2°C↑</a:t>
-            </a:r>
-          </a:p>
-          <a:p>
-            <a:pPr algn="l">
-              <a:lnSpc>
-                <a:spcPct val="108000"/>
-              </a:lnSpc>
-              <a:spcAft>
-                <a:spcPts val="900"/>
-              </a:spcAft>
-            </a:pPr>
+                  <a:srgbClr val="5A6B7B"/>
+                </a:solidFill>
+                <a:latin typeface="NanumGothic"/>
+                <a:ea typeface="NanumGothic"/>
+              </a:rPr>
+              <a:t/>
+            </a:r>
             <a:r>
               <a:rPr sz="1350" b="1" i="0">
                 <a:solidFill>
-                  <a:srgbClr val="5A6B7B"/>
-                </a:solidFill>
-                <a:latin typeface="NanumGothic"/>
-                <a:ea typeface="NanumGothic"/>
-              </a:rPr>
-              <a:t/>
-            </a:r>
-            <a:r>
-              <a:rPr sz="1350" b="1" i="0">
-                <a:solidFill>
                   <a:srgbClr val="1F6E70"/>
                 </a:solidFill>
                 <a:latin typeface="NanumGothic"/>
                 <a:ea typeface="NanumGothic"/>
               </a:rPr>
-              <a:t>약제: 국소마취제 / 신경파괴는 진단차단 양성 시에만</a:t>
+              <a:t>조영제 두미측 확산 · 측면상 전방 1/3 · 성공지표 온도 ≥2°C↑</a:t>
             </a:r>
           </a:p>
         </p:txBody>
@@ -15405,7 +15405,7 @@
                 <a:latin typeface="NanumGothic"/>
                 <a:ea typeface="NanumGothic"/>
               </a:rPr>
-              <a:t>근거: StatPearls NBK431107 · NBK560514 · 측면 모식도</a:t>
+              <a:t>근거: 약제: 국소마취제 / 신경파괴는 진단차단 양성 시에만 · StatPearls NBK431107 · NBK560514</a:t>
             </a:r>
           </a:p>
         </p:txBody>

</xml_diff>